<commit_message>
Update Parent Night Slides
</commit_message>
<xml_diff>
--- a/files/2026_Parent_Night.pptx
+++ b/files/2026_Parent_Night.pptx
@@ -5,7 +5,7 @@
     <p:sldMasterId id="2147483648" r:id="rId4"/>
   </p:sldMasterIdLst>
   <p:notesMasterIdLst>
-    <p:notesMasterId r:id="rId23"/>
+    <p:notesMasterId r:id="rId24"/>
   </p:notesMasterIdLst>
   <p:sldIdLst>
     <p:sldId id="256" r:id="rId5"/>
@@ -19,28 +19,29 @@
     <p:sldId id="275" r:id="rId13"/>
     <p:sldId id="269" r:id="rId14"/>
     <p:sldId id="260" r:id="rId15"/>
-    <p:sldId id="272" r:id="rId16"/>
-    <p:sldId id="271" r:id="rId17"/>
-    <p:sldId id="265" r:id="rId18"/>
-    <p:sldId id="266" r:id="rId19"/>
-    <p:sldId id="273" r:id="rId20"/>
-    <p:sldId id="267" r:id="rId21"/>
-    <p:sldId id="268" r:id="rId22"/>
+    <p:sldId id="276" r:id="rId16"/>
+    <p:sldId id="272" r:id="rId17"/>
+    <p:sldId id="271" r:id="rId18"/>
+    <p:sldId id="265" r:id="rId19"/>
+    <p:sldId id="266" r:id="rId20"/>
+    <p:sldId id="273" r:id="rId21"/>
+    <p:sldId id="267" r:id="rId22"/>
+    <p:sldId id="268" r:id="rId23"/>
   </p:sldIdLst>
   <p:sldSz cx="6400800" cy="3657600"/>
   <p:notesSz cx="6858000" cy="9144000"/>
   <p:embeddedFontLst>
     <p:embeddedFont>
       <p:font typeface="Roboto Black" panose="02000000000000000000" pitchFamily="2" charset="0"/>
-      <p:bold r:id="rId24"/>
-      <p:boldItalic r:id="rId25"/>
+      <p:bold r:id="rId25"/>
+      <p:boldItalic r:id="rId26"/>
     </p:embeddedFont>
     <p:embeddedFont>
       <p:font typeface="Roboto Medium" panose="02000000000000000000" pitchFamily="2" charset="0"/>
-      <p:regular r:id="rId26"/>
-      <p:bold r:id="rId27"/>
-      <p:italic r:id="rId28"/>
-      <p:boldItalic r:id="rId29"/>
+      <p:regular r:id="rId27"/>
+      <p:bold r:id="rId28"/>
+      <p:italic r:id="rId29"/>
+      <p:boldItalic r:id="rId30"/>
     </p:embeddedFont>
   </p:embeddedFontLst>
   <p:defaultTextStyle>
@@ -277,7 +278,7 @@
       <p15:sldGuideLst xmlns:p15="http://schemas.microsoft.com/office/powerpoint/2012/main"/>
     </p:ext>
     <p:ext uri="GoogleSlidesCustomDataVersion2">
-      <go:slidesCustomData xmlns="" xmlns:mc="http://schemas.openxmlformats.org/markup-compatibility/2006" xmlns:mv="urn:schemas-microsoft-com:mac:vml" xmlns:c="http://schemas.openxmlformats.org/drawingml/2006/chart" xmlns:dgm="http://schemas.openxmlformats.org/drawingml/2006/diagram" xmlns:o="urn:schemas-microsoft-com:office:office" xmlns:v="urn:schemas-microsoft-com:vml" xmlns:pvml="urn:schemas-microsoft-com:office:powerpoint" xmlns:com="http://schemas.openxmlformats.org/drawingml/2006/compatibility" xmlns:p14="http://schemas.microsoft.com/office/powerpoint/2010/main" xmlns:p15="http://schemas.microsoft.com/office/powerpoint/2012/main" xmlns:ahyp="http://schemas.microsoft.com/office/drawing/2018/hyperlinkcolor" xmlns:go="http://customooxmlschemas.google.com/" r:id="rId30" roundtripDataSignature="AMtx7mivQF3WycM3EW7P8rYwDTK70z41OQ=="/>
+      <go:slidesCustomData xmlns="" xmlns:mc="http://schemas.openxmlformats.org/markup-compatibility/2006" xmlns:mv="urn:schemas-microsoft-com:mac:vml" xmlns:c="http://schemas.openxmlformats.org/drawingml/2006/chart" xmlns:dgm="http://schemas.openxmlformats.org/drawingml/2006/diagram" xmlns:o="urn:schemas-microsoft-com:office:office" xmlns:v="urn:schemas-microsoft-com:vml" xmlns:pvml="urn:schemas-microsoft-com:office:powerpoint" xmlns:com="http://schemas.openxmlformats.org/drawingml/2006/compatibility" xmlns:p14="http://schemas.microsoft.com/office/powerpoint/2010/main" xmlns:p15="http://schemas.microsoft.com/office/powerpoint/2012/main" xmlns:ahyp="http://schemas.microsoft.com/office/drawing/2018/hyperlinkcolor" xmlns:go="http://customooxmlschemas.google.com/" r:id="rId31" roundtripDataSignature="AMtx7mivQF3WycM3EW7P8rYwDTK70z41OQ=="/>
     </p:ext>
   </p:extLst>
 </p:presentation>
@@ -13920,6 +13921,113 @@
           <p:cNvPr id="2" name="Title 1">
             <a:extLst>
               <a:ext uri="{FF2B5EF4-FFF2-40B4-BE49-F238E27FC236}">
+                <a16:creationId xmlns:a16="http://schemas.microsoft.com/office/drawing/2014/main" id="{6E7CD6FA-FD84-8009-8584-3D069016890E}"/>
+              </a:ext>
+            </a:extLst>
+          </p:cNvPr>
+          <p:cNvSpPr>
+            <a:spLocks noGrp="1"/>
+          </p:cNvSpPr>
+          <p:nvPr>
+            <p:ph type="title"/>
+          </p:nvPr>
+        </p:nvSpPr>
+        <p:spPr/>
+        <p:txBody>
+          <a:bodyPr/>
+          <a:lstStyle/>
+          <a:p>
+            <a:r>
+              <a:rPr lang="en-US" dirty="0"/>
+              <a:t>Trainings – Placement </a:t>
+            </a:r>
+            <a:r>
+              <a:rPr lang="en-US"/>
+              <a:t>Tests Registration</a:t>
+            </a:r>
+            <a:endParaRPr lang="en-US" dirty="0"/>
+          </a:p>
+        </p:txBody>
+      </p:sp>
+      <p:sp>
+        <p:nvSpPr>
+          <p:cNvPr id="3" name="Text Placeholder 2">
+            <a:extLst>
+              <a:ext uri="{FF2B5EF4-FFF2-40B4-BE49-F238E27FC236}">
+                <a16:creationId xmlns:a16="http://schemas.microsoft.com/office/drawing/2014/main" id="{77F6497A-7944-0C7F-7E20-00AD90B8E1D4}"/>
+              </a:ext>
+            </a:extLst>
+          </p:cNvPr>
+          <p:cNvSpPr>
+            <a:spLocks noGrp="1"/>
+          </p:cNvSpPr>
+          <p:nvPr>
+            <p:ph type="body" idx="1"/>
+          </p:nvPr>
+        </p:nvSpPr>
+        <p:spPr/>
+        <p:txBody>
+          <a:bodyPr/>
+          <a:lstStyle/>
+          <a:p>
+            <a:r>
+              <a:rPr lang="en-US" dirty="0"/>
+              <a:t>Details: </a:t>
+            </a:r>
+            <a:r>
+              <a:rPr lang="en-US" dirty="0">
+                <a:hlinkClick r:id="rId2"/>
+              </a:rPr>
+              <a:t>https://rmsmath.sharplogic.com/competitions/</a:t>
+            </a:r>
+            <a:r>
+              <a:rPr lang="en-US" dirty="0"/>
+              <a:t> </a:t>
+            </a:r>
+          </a:p>
+          <a:p>
+            <a:r>
+              <a:rPr lang="en-US" dirty="0"/>
+              <a:t>Registration Deadline: September 20, 2026</a:t>
+            </a:r>
+          </a:p>
+        </p:txBody>
+      </p:sp>
+    </p:spTree>
+    <p:extLst>
+      <p:ext uri="{BB962C8B-B14F-4D97-AF65-F5344CB8AC3E}">
+        <p14:creationId xmlns:p14="http://schemas.microsoft.com/office/powerpoint/2010/main" val="1249000707"/>
+      </p:ext>
+    </p:extLst>
+  </p:cSld>
+  <p:clrMapOvr>
+    <a:masterClrMapping/>
+  </p:clrMapOvr>
+</p:sld>
+</file>
+
+<file path=ppt/slides/slide13.xml><?xml version="1.0" encoding="utf-8"?>
+<p:sld xmlns:a="http://schemas.openxmlformats.org/drawingml/2006/main" xmlns:r="http://schemas.openxmlformats.org/officeDocument/2006/relationships" xmlns:p="http://schemas.openxmlformats.org/presentationml/2006/main">
+  <p:cSld>
+    <p:spTree>
+      <p:nvGrpSpPr>
+        <p:cNvPr id="1" name=""/>
+        <p:cNvGrpSpPr/>
+        <p:nvPr/>
+      </p:nvGrpSpPr>
+      <p:grpSpPr>
+        <a:xfrm>
+          <a:off x="0" y="0"/>
+          <a:ext cx="0" cy="0"/>
+          <a:chOff x="0" y="0"/>
+          <a:chExt cx="0" cy="0"/>
+        </a:xfrm>
+      </p:grpSpPr>
+      <p:sp>
+        <p:nvSpPr>
+          <p:cNvPr id="2" name="Title 1">
+            <a:extLst>
+              <a:ext uri="{FF2B5EF4-FFF2-40B4-BE49-F238E27FC236}">
                 <a16:creationId xmlns:a16="http://schemas.microsoft.com/office/drawing/2014/main" id="{D7E94E81-D97C-E572-A5E6-C67240F8637D}"/>
               </a:ext>
             </a:extLst>
@@ -14009,7 +14117,7 @@
 </p:sld>
 </file>
 
-<file path=ppt/slides/slide13.xml><?xml version="1.0" encoding="utf-8"?>
+<file path=ppt/slides/slide14.xml><?xml version="1.0" encoding="utf-8"?>
 <p:sld xmlns:a="http://schemas.openxmlformats.org/drawingml/2006/main" xmlns:r="http://schemas.openxmlformats.org/officeDocument/2006/relationships" xmlns:p="http://schemas.openxmlformats.org/presentationml/2006/main">
   <p:cSld>
     <p:spTree>
@@ -14170,7 +14278,7 @@
 </p:sld>
 </file>
 
-<file path=ppt/slides/slide14.xml><?xml version="1.0" encoding="utf-8"?>
+<file path=ppt/slides/slide15.xml><?xml version="1.0" encoding="utf-8"?>
 <p:sld xmlns:a="http://schemas.openxmlformats.org/drawingml/2006/main" xmlns:r="http://schemas.openxmlformats.org/officeDocument/2006/relationships" xmlns:p="http://schemas.openxmlformats.org/presentationml/2006/main">
   <p:cSld>
     <p:spTree>
@@ -14744,7 +14852,7 @@
 </p:sld>
 </file>
 
-<file path=ppt/slides/slide15.xml><?xml version="1.0" encoding="utf-8"?>
+<file path=ppt/slides/slide16.xml><?xml version="1.0" encoding="utf-8"?>
 <p:sld xmlns:a="http://schemas.openxmlformats.org/drawingml/2006/main" xmlns:r="http://schemas.openxmlformats.org/officeDocument/2006/relationships" xmlns:p="http://schemas.openxmlformats.org/presentationml/2006/main">
   <p:cSld>
     <p:spTree>
@@ -15023,7 +15131,7 @@
 </p:sld>
 </file>
 
-<file path=ppt/slides/slide16.xml><?xml version="1.0" encoding="utf-8"?>
+<file path=ppt/slides/slide17.xml><?xml version="1.0" encoding="utf-8"?>
 <p:sld xmlns:a="http://schemas.openxmlformats.org/drawingml/2006/main" xmlns:r="http://schemas.openxmlformats.org/officeDocument/2006/relationships" xmlns:p="http://schemas.openxmlformats.org/presentationml/2006/main">
   <p:cSld>
     <p:spTree>
@@ -15141,7 +15249,7 @@
 </p:sld>
 </file>
 
-<file path=ppt/slides/slide17.xml><?xml version="1.0" encoding="utf-8"?>
+<file path=ppt/slides/slide18.xml><?xml version="1.0" encoding="utf-8"?>
 <p:sld xmlns:a="http://schemas.openxmlformats.org/drawingml/2006/main" xmlns:r="http://schemas.openxmlformats.org/officeDocument/2006/relationships" xmlns:p="http://schemas.openxmlformats.org/presentationml/2006/main">
   <p:cSld>
     <p:spTree>
@@ -15846,7 +15954,7 @@
 </p:sld>
 </file>
 
-<file path=ppt/slides/slide18.xml><?xml version="1.0" encoding="utf-8"?>
+<file path=ppt/slides/slide19.xml><?xml version="1.0" encoding="utf-8"?>
 <p:sld xmlns:a="http://schemas.openxmlformats.org/drawingml/2006/main" xmlns:r="http://schemas.openxmlformats.org/officeDocument/2006/relationships" xmlns:p="http://schemas.openxmlformats.org/presentationml/2006/main">
   <p:cSld>
     <p:spTree>
@@ -22689,15 +22797,6 @@
 </file>
 
 <file path=customXml/item1.xml><?xml version="1.0" encoding="utf-8"?>
-<?mso-contentType ?>
-<FormTemplates xmlns="http://schemas.microsoft.com/sharepoint/v3/contenttype/forms">
-  <Display>DocumentLibraryForm</Display>
-  <Edit>DocumentLibraryForm</Edit>
-  <New>DocumentLibraryForm</New>
-</FormTemplates>
-</file>
-
-<file path=customXml/item2.xml><?xml version="1.0" encoding="utf-8"?>
 <p:properties xmlns:p="http://schemas.microsoft.com/office/2006/metadata/properties" xmlns:xsi="http://www.w3.org/2001/XMLSchema-instance" xmlns:pc="http://schemas.microsoft.com/office/infopath/2007/PartnerControls">
   <documentManagement>
     <TaxCatchAll xmlns="88c97c8a-6b74-4265-ab58-5d856f0fac8e" xsi:nil="true"/>
@@ -22708,7 +22807,7 @@
 </p:properties>
 </file>
 
-<file path=customXml/item3.xml><?xml version="1.0" encoding="utf-8"?>
+<file path=customXml/item2.xml><?xml version="1.0" encoding="utf-8"?>
 <ct:contentTypeSchema xmlns:ct="http://schemas.microsoft.com/office/2006/metadata/contentType" xmlns:ma="http://schemas.microsoft.com/office/2006/metadata/properties/metaAttributes" ct:_="" ma:_="" ma:contentTypeName="Document" ma:contentTypeID="0x01010013D4C92C4281F94BA845507011A408F6" ma:contentTypeVersion="14" ma:contentTypeDescription="Create a new document." ma:contentTypeScope="" ma:versionID="2dcb87a0db7a7edb2a1ccfecc962be1f">
   <xsd:schema xmlns:xsd="http://www.w3.org/2001/XMLSchema" xmlns:xs="http://www.w3.org/2001/XMLSchema" xmlns:p="http://schemas.microsoft.com/office/2006/metadata/properties" xmlns:ns2="6d99ef51-b4d3-4c25-a476-d000f96f2573" xmlns:ns3="88c97c8a-6b74-4265-ab58-5d856f0fac8e" targetNamespace="http://schemas.microsoft.com/office/2006/metadata/properties" ma:root="true" ma:fieldsID="67c9487cd5ad19e710d2cbca47d9ce88" ns2:_="" ns3:_="">
     <xsd:import namespace="6d99ef51-b4d3-4c25-a476-d000f96f2573"/>
@@ -22937,15 +23036,16 @@
 </ct:contentTypeSchema>
 </file>
 
-<file path=customXml/itemProps1.xml><?xml version="1.0" encoding="utf-8"?>
-<ds:datastoreItem xmlns:ds="http://schemas.openxmlformats.org/officeDocument/2006/customXml" ds:itemID="{89982E13-39B7-4100-B339-199D4F3922F4}">
-  <ds:schemaRefs>
-    <ds:schemaRef ds:uri="http://schemas.microsoft.com/sharepoint/v3/contenttype/forms"/>
-  </ds:schemaRefs>
-</ds:datastoreItem>
+<file path=customXml/item3.xml><?xml version="1.0" encoding="utf-8"?>
+<?mso-contentType ?>
+<FormTemplates xmlns="http://schemas.microsoft.com/sharepoint/v3/contenttype/forms">
+  <Display>DocumentLibraryForm</Display>
+  <Edit>DocumentLibraryForm</Edit>
+  <New>DocumentLibraryForm</New>
+</FormTemplates>
 </file>
 
-<file path=customXml/itemProps2.xml><?xml version="1.0" encoding="utf-8"?>
+<file path=customXml/itemProps1.xml><?xml version="1.0" encoding="utf-8"?>
 <ds:datastoreItem xmlns:ds="http://schemas.openxmlformats.org/officeDocument/2006/customXml" ds:itemID="{11FFBCBE-134F-4DEE-BCD5-DE836EB0D747}">
   <ds:schemaRefs>
     <ds:schemaRef ds:uri="http://schemas.microsoft.com/office/2006/metadata/properties"/>
@@ -22956,7 +23056,7 @@
 </ds:datastoreItem>
 </file>
 
-<file path=customXml/itemProps3.xml><?xml version="1.0" encoding="utf-8"?>
+<file path=customXml/itemProps2.xml><?xml version="1.0" encoding="utf-8"?>
 <ds:datastoreItem xmlns:ds="http://schemas.openxmlformats.org/officeDocument/2006/customXml" ds:itemID="{2BE0D24D-CE65-4F19-A6F6-D854C4F83F42}">
   <ds:schemaRefs>
     <ds:schemaRef ds:uri="http://schemas.microsoft.com/office/2006/metadata/contentType"/>
@@ -22973,4 +23073,12 @@
     <ds:schemaRef ds:uri="http://schemas.microsoft.com/internal/obd"/>
   </ds:schemaRefs>
 </ds:datastoreItem>
+</file>
+
+<file path=customXml/itemProps3.xml><?xml version="1.0" encoding="utf-8"?>
+<ds:datastoreItem xmlns:ds="http://schemas.openxmlformats.org/officeDocument/2006/customXml" ds:itemID="{89982E13-39B7-4100-B339-199D4F3922F4}">
+  <ds:schemaRefs>
+    <ds:schemaRef ds:uri="http://schemas.microsoft.com/sharepoint/v3/contenttype/forms"/>
+  </ds:schemaRefs>
+</ds:datastoreItem>
 </file>
</xml_diff>